<commit_message>
Presentation: PDF and image-based deck that look the same in Keynote and PowerPoint
Checked every slide with Georgia-metric fonts (Gelasio) instead of a wider
substitute. Big numbers now use Arial. Adds a PDF and an image-per-slide PPTX
with speaker notes, so the layout cannot shift in Keynote or PowerPoint.

Claude-Session: https://claude.ai/code/session_01HjGxXR8tkn4Ub6BmPgpamX
</commit_message>
<xml_diff>
--- a/reports/Presentasi_Penerjemah_Aceh_Indonesia.pptx
+++ b/reports/Presentasi_Penerjemah_Aceh_Indonesia.pptx
@@ -138,13 +138,13 @@
   <p:extLst>
     <p:ext uri="{521415D9-36F7-43E2-AB2F-B90AF26B5E84}">
       <p14:sectionLst xmlns:p14="http://schemas.microsoft.com/office/powerpoint/2010/main">
-        <p14:section name="Pembuka" id="{3a1c3da6-b1d8-9b7f-f31a-136a42c0310d}">
+        <p14:section name="Pembuka" id="{83321b2a-e4b0-fc4d-f30e-2a9f85aa38c2}">
           <p14:sldIdLst>
             <p14:sldId id="256"/>
             <p14:sldId id="257"/>
           </p14:sldIdLst>
         </p14:section>
-        <p14:section name="Gambaran" id="{3a1ad8cd-d7da-dda0-f1f5-f86125ba6747}">
+        <p14:section name="Gambaran" id="{00d93d23-49e7-8b76-dca9-750d6290edaa}">
           <p14:sldIdLst>
             <p14:sldId id="258"/>
             <p14:sldId id="259"/>
@@ -154,7 +154,7 @@
             <p14:sldId id="263"/>
           </p14:sldIdLst>
         </p14:section>
-        <p14:section name="Data" id="{a9bec663-1a58-ca62-0380-3a0d871697e8}">
+        <p14:section name="Data" id="{d46905ee-6fae-e8c7-17ec-7421532a34d1}">
           <p14:sldIdLst>
             <p14:sldId id="264"/>
             <p14:sldId id="265"/>
@@ -167,13 +167,13 @@
             <p14:sldId id="272"/>
           </p14:sldIdLst>
         </p14:section>
-        <p14:section name="Metode" id="{381e0333-6667-ee74-d32d-4e1c299aae44}">
+        <p14:section name="Metode" id="{3c43de9e-598b-fc2e-b309-71d8b9088f83}">
           <p14:sldIdLst>
             <p14:sldId id="273"/>
             <p14:sldId id="274"/>
           </p14:sldIdLst>
         </p14:section>
-        <p14:section name="Hasil" id="{a9ad1ef1-2b5b-9152-b481-55be878a1e20}">
+        <p14:section name="Hasil" id="{8eb69479-cf44-f881-20f0-0d706b27544e}">
           <p14:sldIdLst>
             <p14:sldId id="275"/>
             <p14:sldId id="276"/>
@@ -184,14 +184,14 @@
             <p14:sldId id="281"/>
           </p14:sldIdLst>
         </p14:section>
-        <p14:section name="Aplikasi" id="{b67390cc-0fdd-7293-9d02-afb560208b57}">
+        <p14:section name="Aplikasi" id="{4b373416-8d5a-0f40-bd47-a8e877d8f167}">
           <p14:sldIdLst>
             <p14:sldId id="282"/>
             <p14:sldId id="283"/>
             <p14:sldId id="284"/>
           </p14:sldIdLst>
         </p14:section>
-        <p14:section name="Penutup" id="{46f9c945-ff6c-5256-c802-9625338bef24}">
+        <p14:section name="Penutup" id="{39034b10-3384-205f-3785-3c060559aed4}">
           <p14:sldIdLst>
             <p14:sldId id="285"/>
             <p14:sldId id="286"/>
@@ -4227,9 +4227,6 @@
                 <a:solidFill>
                   <a:schemeClr val="bg1"/>
                 </a:solidFill>
-                <a:latin typeface="Georgia" pitchFamily="34" charset="0"/>
-                <a:ea typeface="Georgia" pitchFamily="34" charset="-122"/>
-                <a:cs typeface="Georgia" pitchFamily="34" charset="-120"/>
               </a:rPr>
               <a:t>17.547</a:t>
             </a:r>
@@ -4302,9 +4299,6 @@
                 <a:solidFill>
                   <a:schemeClr val="tx2"/>
                 </a:solidFill>
-                <a:latin typeface="Georgia" pitchFamily="34" charset="0"/>
-                <a:ea typeface="Georgia" pitchFamily="34" charset="-122"/>
-                <a:cs typeface="Georgia" pitchFamily="34" charset="-120"/>
               </a:rPr>
               <a:t>57,1</a:t>
             </a:r>
@@ -5580,9 +5574,6 @@
                 <a:solidFill>
                   <a:schemeClr val="accent1"/>
                 </a:solidFill>
-                <a:latin typeface="Georgia" pitchFamily="34" charset="0"/>
-                <a:ea typeface="Georgia" pitchFamily="34" charset="-122"/>
-                <a:cs typeface="Georgia" pitchFamily="34" charset="-120"/>
               </a:rPr>
               <a:t>63.346</a:t>
             </a:r>
@@ -5682,9 +5673,6 @@
                 <a:solidFill>
                   <a:schemeClr val="accent1"/>
                 </a:solidFill>
-                <a:latin typeface="Georgia" pitchFamily="34" charset="0"/>
-                <a:ea typeface="Georgia" pitchFamily="34" charset="-122"/>
-                <a:cs typeface="Georgia" pitchFamily="34" charset="-120"/>
               </a:rPr>
               <a:t>15.995</a:t>
             </a:r>
@@ -6358,9 +6346,6 @@
                 <a:solidFill>
                   <a:schemeClr val="accent1"/>
                 </a:solidFill>
-                <a:latin typeface="Georgia" pitchFamily="34" charset="0"/>
-                <a:ea typeface="Georgia" pitchFamily="34" charset="-122"/>
-                <a:cs typeface="Georgia" pitchFamily="34" charset="-120"/>
               </a:rPr>
               <a:t>2,31%</a:t>
             </a:r>
@@ -6460,9 +6445,6 @@
                 <a:solidFill>
                   <a:schemeClr val="accent1"/>
                 </a:solidFill>
-                <a:latin typeface="Georgia" pitchFamily="34" charset="0"/>
-                <a:ea typeface="Georgia" pitchFamily="34" charset="-122"/>
-                <a:cs typeface="Georgia" pitchFamily="34" charset="-120"/>
               </a:rPr>
               <a:t>80</a:t>
             </a:r>
@@ -6562,9 +6544,6 @@
                 <a:solidFill>
                   <a:schemeClr val="accent1"/>
                 </a:solidFill>
-                <a:latin typeface="Georgia" pitchFamily="34" charset="0"/>
-                <a:ea typeface="Georgia" pitchFamily="34" charset="-122"/>
-                <a:cs typeface="Georgia" pitchFamily="34" charset="-120"/>
               </a:rPr>
               <a:t>Penutur</a:t>
             </a:r>
@@ -7681,9 +7660,6 @@
                 <a:solidFill>
                   <a:schemeClr val="accent1"/>
                 </a:solidFill>
-                <a:latin typeface="Georgia" pitchFamily="34" charset="0"/>
-                <a:ea typeface="Georgia" pitchFamily="34" charset="-122"/>
-                <a:cs typeface="Georgia" pitchFamily="34" charset="-120"/>
               </a:rPr>
               <a:t>379</a:t>
             </a:r>
@@ -7819,9 +7795,6 @@
                 <a:solidFill>
                   <a:schemeClr val="accent1"/>
                 </a:solidFill>
-                <a:latin typeface="Georgia" pitchFamily="34" charset="0"/>
-                <a:ea typeface="Georgia" pitchFamily="34" charset="-122"/>
-                <a:cs typeface="Georgia" pitchFamily="34" charset="-120"/>
               </a:rPr>
               <a:t>400</a:t>
             </a:r>
@@ -7894,9 +7867,6 @@
                 <a:solidFill>
                   <a:schemeClr val="accent1"/>
                 </a:solidFill>
-                <a:latin typeface="Georgia" pitchFamily="34" charset="0"/>
-                <a:ea typeface="Georgia" pitchFamily="34" charset="-122"/>
-                <a:cs typeface="Georgia" pitchFamily="34" charset="-120"/>
               </a:rPr>
               <a:t>1.012</a:t>
             </a:r>
@@ -7969,9 +7939,6 @@
                 <a:solidFill>
                   <a:schemeClr val="accent1"/>
                 </a:solidFill>
-                <a:latin typeface="Georgia" pitchFamily="34" charset="0"/>
-                <a:ea typeface="Georgia" pitchFamily="34" charset="-122"/>
-                <a:cs typeface="Georgia" pitchFamily="34" charset="-120"/>
               </a:rPr>
               <a:t>143</a:t>
             </a:r>
@@ -8860,9 +8827,6 @@
                 <a:solidFill>
                   <a:schemeClr val="accent1"/>
                 </a:solidFill>
-                <a:latin typeface="Georgia" pitchFamily="34" charset="0"/>
-                <a:ea typeface="Georgia" pitchFamily="34" charset="-122"/>
-                <a:cs typeface="Georgia" pitchFamily="34" charset="-120"/>
               </a:rPr>
               <a:t>11,3% → 0,8%</a:t>
             </a:r>
@@ -8962,9 +8926,6 @@
                 <a:solidFill>
                   <a:schemeClr val="accent1"/>
                 </a:solidFill>
-                <a:latin typeface="Georgia" pitchFamily="34" charset="0"/>
-                <a:ea typeface="Georgia" pitchFamily="34" charset="-122"/>
-                <a:cs typeface="Georgia" pitchFamily="34" charset="-120"/>
               </a:rPr>
               <a:t>1.856</a:t>
             </a:r>
@@ -9064,9 +9025,6 @@
                 <a:solidFill>
                   <a:schemeClr val="accent1"/>
                 </a:solidFill>
-                <a:latin typeface="Georgia" pitchFamily="34" charset="0"/>
-                <a:ea typeface="Georgia" pitchFamily="34" charset="-122"/>
-                <a:cs typeface="Georgia" pitchFamily="34" charset="-120"/>
               </a:rPr>
               <a:t>1.654</a:t>
             </a:r>
@@ -9166,9 +9124,6 @@
                 <a:solidFill>
                   <a:schemeClr val="accent1"/>
                 </a:solidFill>
-                <a:latin typeface="Georgia" pitchFamily="34" charset="0"/>
-                <a:ea typeface="Georgia" pitchFamily="34" charset="-122"/>
-                <a:cs typeface="Georgia" pitchFamily="34" charset="-120"/>
               </a:rPr>
               <a:t>40 dari 40</a:t>
             </a:r>
@@ -9497,9 +9452,6 @@
                 <a:solidFill>
                   <a:schemeClr val="accent5"/>
                 </a:solidFill>
-                <a:latin typeface="Georgia" pitchFamily="34" charset="0"/>
-                <a:ea typeface="Georgia" pitchFamily="34" charset="-122"/>
-                <a:cs typeface="Georgia" pitchFamily="34" charset="-120"/>
               </a:rPr>
               <a:t>1.030</a:t>
             </a:r>
@@ -9572,9 +9524,6 @@
                 <a:solidFill>
                   <a:schemeClr val="accent1"/>
                 </a:solidFill>
-                <a:latin typeface="Georgia" pitchFamily="34" charset="0"/>
-                <a:ea typeface="Georgia" pitchFamily="34" charset="-122"/>
-                <a:cs typeface="Georgia" pitchFamily="34" charset="-120"/>
               </a:rPr>
               <a:t>350</a:t>
             </a:r>
@@ -9795,9 +9744,6 @@
                 <a:solidFill>
                   <a:schemeClr val="accent5"/>
                 </a:solidFill>
-                <a:latin typeface="Georgia" pitchFamily="34" charset="0"/>
-                <a:ea typeface="Georgia" pitchFamily="34" charset="-122"/>
-                <a:cs typeface="Georgia" pitchFamily="34" charset="-120"/>
               </a:rPr>
               <a:t>5.000</a:t>
             </a:r>
@@ -9870,9 +9816,6 @@
                 <a:solidFill>
                   <a:schemeClr val="accent1"/>
                 </a:solidFill>
-                <a:latin typeface="Georgia" pitchFamily="34" charset="0"/>
-                <a:ea typeface="Georgia" pitchFamily="34" charset="-122"/>
-                <a:cs typeface="Georgia" pitchFamily="34" charset="-120"/>
               </a:rPr>
               <a:t>2.798</a:t>
             </a:r>
@@ -10093,9 +10036,6 @@
                 <a:solidFill>
                   <a:schemeClr val="accent5"/>
                 </a:solidFill>
-                <a:latin typeface="Georgia" pitchFamily="34" charset="0"/>
-                <a:ea typeface="Georgia" pitchFamily="34" charset="-122"/>
-                <a:cs typeface="Georgia" pitchFamily="34" charset="-120"/>
               </a:rPr>
               <a:t>103</a:t>
             </a:r>
@@ -10168,9 +10108,6 @@
                 <a:solidFill>
                   <a:schemeClr val="accent1"/>
                 </a:solidFill>
-                <a:latin typeface="Georgia" pitchFamily="34" charset="0"/>
-                <a:ea typeface="Georgia" pitchFamily="34" charset="-122"/>
-                <a:cs typeface="Georgia" pitchFamily="34" charset="-120"/>
               </a:rPr>
               <a:t>96</a:t>
             </a:r>
@@ -11078,9 +11015,6 @@
                 <a:solidFill>
                   <a:schemeClr val="accent1"/>
                 </a:solidFill>
-                <a:latin typeface="Georgia" pitchFamily="34" charset="0"/>
-                <a:ea typeface="Georgia" pitchFamily="34" charset="-122"/>
-                <a:cs typeface="Georgia" pitchFamily="34" charset="-120"/>
               </a:rPr>
               <a:t>5.750</a:t>
             </a:r>
@@ -11153,9 +11087,6 @@
                 <a:solidFill>
                   <a:schemeClr val="accent1"/>
                 </a:solidFill>
-                <a:latin typeface="Georgia" pitchFamily="34" charset="0"/>
-                <a:ea typeface="Georgia" pitchFamily="34" charset="-122"/>
-                <a:cs typeface="Georgia" pitchFamily="34" charset="-120"/>
               </a:rPr>
               <a:t>5.733</a:t>
             </a:r>
@@ -12305,9 +12236,6 @@
                 <a:solidFill>
                   <a:schemeClr val="accent1"/>
                 </a:solidFill>
-                <a:latin typeface="Georgia" pitchFamily="34" charset="0"/>
-                <a:ea typeface="Georgia" pitchFamily="34" charset="-122"/>
-                <a:cs typeface="Georgia" pitchFamily="34" charset="-120"/>
               </a:rPr>
               <a:t>1</a:t>
             </a:r>
@@ -12407,9 +12335,6 @@
                 <a:solidFill>
                   <a:schemeClr val="accent1"/>
                 </a:solidFill>
-                <a:latin typeface="Georgia" pitchFamily="34" charset="0"/>
-                <a:ea typeface="Georgia" pitchFamily="34" charset="-122"/>
-                <a:cs typeface="Georgia" pitchFamily="34" charset="-120"/>
               </a:rPr>
               <a:t>2</a:t>
             </a:r>
@@ -12509,9 +12434,6 @@
                 <a:solidFill>
                   <a:schemeClr val="accent1"/>
                 </a:solidFill>
-                <a:latin typeface="Georgia" pitchFamily="34" charset="0"/>
-                <a:ea typeface="Georgia" pitchFamily="34" charset="-122"/>
-                <a:cs typeface="Georgia" pitchFamily="34" charset="-120"/>
               </a:rPr>
               <a:t>3</a:t>
             </a:r>
@@ -12611,9 +12533,6 @@
                 <a:solidFill>
                   <a:schemeClr val="accent1"/>
                 </a:solidFill>
-                <a:latin typeface="Georgia" pitchFamily="34" charset="0"/>
-                <a:ea typeface="Georgia" pitchFamily="34" charset="-122"/>
-                <a:cs typeface="Georgia" pitchFamily="34" charset="-120"/>
               </a:rPr>
               <a:t>4</a:t>
             </a:r>
@@ -12713,9 +12632,6 @@
                 <a:solidFill>
                   <a:schemeClr val="accent1"/>
                 </a:solidFill>
-                <a:latin typeface="Georgia" pitchFamily="34" charset="0"/>
-                <a:ea typeface="Georgia" pitchFamily="34" charset="-122"/>
-                <a:cs typeface="Georgia" pitchFamily="34" charset="-120"/>
               </a:rPr>
               <a:t>5</a:t>
             </a:r>
@@ -12815,9 +12731,6 @@
                 <a:solidFill>
                   <a:srgbClr val="FFFFFF"/>
                 </a:solidFill>
-                <a:latin typeface="Georgia" pitchFamily="34" charset="0"/>
-                <a:ea typeface="Georgia" pitchFamily="34" charset="-122"/>
-                <a:cs typeface="Georgia" pitchFamily="34" charset="-120"/>
               </a:rPr>
               <a:t>17.547</a:t>
             </a:r>
@@ -12917,9 +12830,6 @@
                 <a:solidFill>
                   <a:srgbClr val="12303A"/>
                 </a:solidFill>
-                <a:latin typeface="Georgia" pitchFamily="34" charset="0"/>
-                <a:ea typeface="Georgia" pitchFamily="34" charset="-122"/>
-                <a:cs typeface="Georgia" pitchFamily="34" charset="-120"/>
               </a:rPr>
               <a:t>379</a:t>
             </a:r>
@@ -13019,9 +12929,6 @@
                 <a:solidFill>
                   <a:srgbClr val="FFFFFF"/>
                 </a:solidFill>
-                <a:latin typeface="Georgia" pitchFamily="34" charset="0"/>
-                <a:ea typeface="Georgia" pitchFamily="34" charset="-122"/>
-                <a:cs typeface="Georgia" pitchFamily="34" charset="-120"/>
               </a:rPr>
               <a:t>1.555</a:t>
             </a:r>
@@ -16133,9 +16040,6 @@
                 <a:solidFill>
                   <a:schemeClr val="accent1"/>
                 </a:solidFill>
-                <a:latin typeface="Georgia" pitchFamily="34" charset="0"/>
-                <a:ea typeface="Georgia" pitchFamily="34" charset="-122"/>
-                <a:cs typeface="Georgia" pitchFamily="34" charset="-120"/>
               </a:rPr>
               <a:t>Epoch 3 dari 5</a:t>
             </a:r>
@@ -16235,9 +16139,6 @@
                 <a:solidFill>
                   <a:schemeClr val="accent1"/>
                 </a:solidFill>
-                <a:latin typeface="Georgia" pitchFamily="34" charset="0"/>
-                <a:ea typeface="Georgia" pitchFamily="34" charset="-122"/>
-                <a:cs typeface="Georgia" pitchFamily="34" charset="-120"/>
               </a:rPr>
               <a:t>3,39 → 2,31</a:t>
             </a:r>
@@ -16337,9 +16238,6 @@
                 <a:solidFill>
                   <a:schemeClr val="accent1"/>
                 </a:solidFill>
-                <a:latin typeface="Georgia" pitchFamily="34" charset="0"/>
-                <a:ea typeface="Georgia" pitchFamily="34" charset="-122"/>
-                <a:cs typeface="Georgia" pitchFamily="34" charset="-120"/>
               </a:rPr>
               <a:t>GPU T4</a:t>
             </a:r>
@@ -16608,9 +16506,6 @@
                 <a:solidFill>
                   <a:schemeClr val="bg1"/>
                 </a:solidFill>
-                <a:latin typeface="Georgia" pitchFamily="34" charset="0"/>
-                <a:ea typeface="Georgia" pitchFamily="34" charset="-122"/>
-                <a:cs typeface="Georgia" pitchFamily="34" charset="-120"/>
               </a:rPr>
               <a:t>AF</a:t>
             </a:r>
@@ -16735,9 +16630,6 @@
                 <a:solidFill>
                   <a:schemeClr val="bg1"/>
                 </a:solidFill>
-                <a:latin typeface="Georgia" pitchFamily="34" charset="0"/>
-                <a:ea typeface="Georgia" pitchFamily="34" charset="-122"/>
-                <a:cs typeface="Georgia" pitchFamily="34" charset="-120"/>
               </a:rPr>
               <a:t>MM</a:t>
             </a:r>
@@ -16862,9 +16754,6 @@
                 <a:solidFill>
                   <a:schemeClr val="bg1"/>
                 </a:solidFill>
-                <a:latin typeface="Georgia" pitchFamily="34" charset="0"/>
-                <a:ea typeface="Georgia" pitchFamily="34" charset="-122"/>
-                <a:cs typeface="Georgia" pitchFamily="34" charset="-120"/>
               </a:rPr>
               <a:t>SR</a:t>
             </a:r>
@@ -16989,9 +16878,6 @@
                 <a:solidFill>
                   <a:schemeClr val="bg1"/>
                 </a:solidFill>
-                <a:latin typeface="Georgia" pitchFamily="34" charset="0"/>
-                <a:ea typeface="Georgia" pitchFamily="34" charset="-122"/>
-                <a:cs typeface="Georgia" pitchFamily="34" charset="-120"/>
               </a:rPr>
               <a:t>MK</a:t>
             </a:r>
@@ -17116,9 +17002,6 @@
                 <a:solidFill>
                   <a:schemeClr val="bg1"/>
                 </a:solidFill>
-                <a:latin typeface="Georgia" pitchFamily="34" charset="0"/>
-                <a:ea typeface="Georgia" pitchFamily="34" charset="-122"/>
-                <a:cs typeface="Georgia" pitchFamily="34" charset="-120"/>
               </a:rPr>
               <a:t>MF</a:t>
             </a:r>
@@ -17243,9 +17126,6 @@
                 <a:solidFill>
                   <a:schemeClr val="bg1"/>
                 </a:solidFill>
-                <a:latin typeface="Georgia" pitchFamily="34" charset="0"/>
-                <a:ea typeface="Georgia" pitchFamily="34" charset="-122"/>
-                <a:cs typeface="Georgia" pitchFamily="34" charset="-120"/>
               </a:rPr>
               <a:t>H</a:t>
             </a:r>
@@ -17370,9 +17250,6 @@
                 <a:solidFill>
                   <a:schemeClr val="bg1"/>
                 </a:solidFill>
-                <a:latin typeface="Georgia" pitchFamily="34" charset="0"/>
-                <a:ea typeface="Georgia" pitchFamily="34" charset="-122"/>
-                <a:cs typeface="Georgia" pitchFamily="34" charset="-120"/>
               </a:rPr>
               <a:t>M</a:t>
             </a:r>
@@ -17497,9 +17374,6 @@
                 <a:solidFill>
                   <a:schemeClr val="bg1"/>
                 </a:solidFill>
-                <a:latin typeface="Georgia" pitchFamily="34" charset="0"/>
-                <a:ea typeface="Georgia" pitchFamily="34" charset="-122"/>
-                <a:cs typeface="Georgia" pitchFamily="34" charset="-120"/>
               </a:rPr>
               <a:t>MR</a:t>
             </a:r>
@@ -17624,9 +17498,6 @@
                 <a:solidFill>
                   <a:schemeClr val="bg1"/>
                 </a:solidFill>
-                <a:latin typeface="Georgia" pitchFamily="34" charset="0"/>
-                <a:ea typeface="Georgia" pitchFamily="34" charset="-122"/>
-                <a:cs typeface="Georgia" pitchFamily="34" charset="-120"/>
               </a:rPr>
               <a:t>MS</a:t>
             </a:r>
@@ -20790,9 +20661,6 @@
                 <a:solidFill>
                   <a:schemeClr val="accent1"/>
                 </a:solidFill>
-                <a:latin typeface="Georgia" pitchFamily="34" charset="0"/>
-                <a:ea typeface="Georgia" pitchFamily="34" charset="-122"/>
-                <a:cs typeface="Georgia" pitchFamily="34" charset="-120"/>
               </a:rPr>
               <a:t>+3,5</a:t>
             </a:r>
@@ -20892,9 +20760,6 @@
                 <a:solidFill>
                   <a:schemeClr val="accent1"/>
                 </a:solidFill>
-                <a:latin typeface="Georgia" pitchFamily="34" charset="0"/>
-                <a:ea typeface="Georgia" pitchFamily="34" charset="-122"/>
-                <a:cs typeface="Georgia" pitchFamily="34" charset="-120"/>
               </a:rPr>
               <a:t>+3,7</a:t>
             </a:r>
@@ -20994,9 +20859,6 @@
                 <a:solidFill>
                   <a:schemeClr val="accent1"/>
                 </a:solidFill>
-                <a:latin typeface="Georgia" pitchFamily="34" charset="0"/>
-                <a:ea typeface="Georgia" pitchFamily="34" charset="-122"/>
-                <a:cs typeface="Georgia" pitchFamily="34" charset="-120"/>
               </a:rPr>
               <a:t>+17,9</a:t>
             </a:r>
@@ -23824,9 +23686,6 @@
                 <a:solidFill>
                   <a:schemeClr val="accent1"/>
                 </a:solidFill>
-                <a:latin typeface="Georgia" pitchFamily="34" charset="0"/>
-                <a:ea typeface="Georgia" pitchFamily="34" charset="-122"/>
-                <a:cs typeface="Georgia" pitchFamily="34" charset="-120"/>
               </a:rPr>
               <a:t>5.260</a:t>
             </a:r>
@@ -23926,9 +23785,6 @@
                 <a:solidFill>
                   <a:schemeClr val="accent1"/>
                 </a:solidFill>
-                <a:latin typeface="Georgia" pitchFamily="34" charset="0"/>
-                <a:ea typeface="Georgia" pitchFamily="34" charset="-122"/>
-                <a:cs typeface="Georgia" pitchFamily="34" charset="-120"/>
               </a:rPr>
               <a:t>266</a:t>
             </a:r>
@@ -27079,9 +26935,6 @@
                 <a:solidFill>
                   <a:schemeClr val="accent1"/>
                 </a:solidFill>
-                <a:latin typeface="Georgia" pitchFamily="34" charset="0"/>
-                <a:ea typeface="Georgia" pitchFamily="34" charset="-122"/>
-                <a:cs typeface="Georgia" pitchFamily="34" charset="-120"/>
               </a:rPr>
               <a:t>91</a:t>
             </a:r>
@@ -27217,9 +27070,6 @@
                 <a:solidFill>
                   <a:schemeClr val="accent1"/>
                 </a:solidFill>
-                <a:latin typeface="Georgia" pitchFamily="34" charset="0"/>
-                <a:ea typeface="Georgia" pitchFamily="34" charset="-122"/>
-                <a:cs typeface="Georgia" pitchFamily="34" charset="-120"/>
               </a:rPr>
               <a:t>1</a:t>
             </a:r>
@@ -27355,9 +27205,6 @@
                 <a:solidFill>
                   <a:schemeClr val="accent1"/>
                 </a:solidFill>
-                <a:latin typeface="Georgia" pitchFamily="34" charset="0"/>
-                <a:ea typeface="Georgia" pitchFamily="34" charset="-122"/>
-                <a:cs typeface="Georgia" pitchFamily="34" charset="-120"/>
               </a:rPr>
               <a:t>Git</a:t>
             </a:r>
@@ -28571,9 +28418,6 @@
                 <a:solidFill>
                   <a:schemeClr val="accent1"/>
                 </a:solidFill>
-                <a:latin typeface="Georgia" pitchFamily="34" charset="0"/>
-                <a:ea typeface="Georgia" pitchFamily="34" charset="-122"/>
-                <a:cs typeface="Georgia" pitchFamily="34" charset="-120"/>
               </a:rPr>
               <a:t>17.547</a:t>
             </a:r>
@@ -28673,9 +28517,6 @@
                 <a:solidFill>
                   <a:schemeClr val="accent1"/>
                 </a:solidFill>
-                <a:latin typeface="Georgia" pitchFamily="34" charset="0"/>
-                <a:ea typeface="Georgia" pitchFamily="34" charset="-122"/>
-                <a:cs typeface="Georgia" pitchFamily="34" charset="-120"/>
               </a:rPr>
               <a:t>57,1</a:t>
             </a:r>
@@ -28775,9 +28616,6 @@
                 <a:solidFill>
                   <a:schemeClr val="accent1"/>
                 </a:solidFill>
-                <a:latin typeface="Georgia" pitchFamily="34" charset="0"/>
-                <a:ea typeface="Georgia" pitchFamily="34" charset="-122"/>
-                <a:cs typeface="Georgia" pitchFamily="34" charset="-120"/>
               </a:rPr>
               <a:t>+36,9</a:t>
             </a:r>
@@ -29999,9 +29837,6 @@
                 <a:solidFill>
                   <a:schemeClr val="accent1"/>
                 </a:solidFill>
-                <a:latin typeface="Georgia" pitchFamily="34" charset="0"/>
-                <a:ea typeface="Georgia" pitchFamily="34" charset="-122"/>
-                <a:cs typeface="Georgia" pitchFamily="34" charset="-120"/>
               </a:rPr>
               <a:t>1</a:t>
             </a:r>
@@ -30101,9 +29936,6 @@
                 <a:solidFill>
                   <a:schemeClr val="accent1"/>
                 </a:solidFill>
-                <a:latin typeface="Georgia" pitchFamily="34" charset="0"/>
-                <a:ea typeface="Georgia" pitchFamily="34" charset="-122"/>
-                <a:cs typeface="Georgia" pitchFamily="34" charset="-120"/>
               </a:rPr>
               <a:t>2</a:t>
             </a:r>
@@ -30203,9 +30035,6 @@
                 <a:solidFill>
                   <a:schemeClr val="accent1"/>
                 </a:solidFill>
-                <a:latin typeface="Georgia" pitchFamily="34" charset="0"/>
-                <a:ea typeface="Georgia" pitchFamily="34" charset="-122"/>
-                <a:cs typeface="Georgia" pitchFamily="34" charset="-120"/>
               </a:rPr>
               <a:t>3</a:t>
             </a:r>
@@ -30305,9 +30134,6 @@
                 <a:solidFill>
                   <a:schemeClr val="accent1"/>
                 </a:solidFill>
-                <a:latin typeface="Georgia" pitchFamily="34" charset="0"/>
-                <a:ea typeface="Georgia" pitchFamily="34" charset="-122"/>
-                <a:cs typeface="Georgia" pitchFamily="34" charset="-120"/>
               </a:rPr>
               <a:t>4</a:t>
             </a:r>
@@ -30407,9 +30233,6 @@
                 <a:solidFill>
                   <a:schemeClr val="accent1"/>
                 </a:solidFill>
-                <a:latin typeface="Georgia" pitchFamily="34" charset="0"/>
-                <a:ea typeface="Georgia" pitchFamily="34" charset="-122"/>
-                <a:cs typeface="Georgia" pitchFamily="34" charset="-120"/>
               </a:rPr>
               <a:t>5</a:t>
             </a:r>
@@ -30509,9 +30332,6 @@
                 <a:solidFill>
                   <a:schemeClr val="accent1"/>
                 </a:solidFill>
-                <a:latin typeface="Georgia" pitchFamily="34" charset="0"/>
-                <a:ea typeface="Georgia" pitchFamily="34" charset="-122"/>
-                <a:cs typeface="Georgia" pitchFamily="34" charset="-120"/>
               </a:rPr>
               <a:t>6</a:t>
             </a:r>
@@ -30611,9 +30431,6 @@
                 <a:solidFill>
                   <a:schemeClr val="accent1"/>
                 </a:solidFill>
-                <a:latin typeface="Georgia" pitchFamily="34" charset="0"/>
-                <a:ea typeface="Georgia" pitchFamily="34" charset="-122"/>
-                <a:cs typeface="Georgia" pitchFamily="34" charset="-120"/>
               </a:rPr>
               <a:t>7</a:t>
             </a:r>
@@ -30713,9 +30530,6 @@
                 <a:solidFill>
                   <a:schemeClr val="accent1"/>
                 </a:solidFill>
-                <a:latin typeface="Georgia" pitchFamily="34" charset="0"/>
-                <a:ea typeface="Georgia" pitchFamily="34" charset="-122"/>
-                <a:cs typeface="Georgia" pitchFamily="34" charset="-120"/>
               </a:rPr>
               <a:t>8</a:t>
             </a:r>
@@ -35489,9 +35303,6 @@
                 <a:solidFill>
                   <a:schemeClr val="tx1"/>
                 </a:solidFill>
-                <a:latin typeface="Georgia" pitchFamily="34" charset="0"/>
-                <a:ea typeface="Georgia" pitchFamily="34" charset="-122"/>
-                <a:cs typeface="Georgia" pitchFamily="34" charset="-120"/>
               </a:rPr>
               <a:t>BLEU</a:t>
             </a:r>
@@ -35640,9 +35451,6 @@
                 <a:solidFill>
                   <a:schemeClr val="tx1"/>
                 </a:solidFill>
-                <a:latin typeface="Georgia" pitchFamily="34" charset="0"/>
-                <a:ea typeface="Georgia" pitchFamily="34" charset="-122"/>
-                <a:cs typeface="Georgia" pitchFamily="34" charset="-120"/>
               </a:rPr>
               <a:t>chrF</a:t>
             </a:r>
@@ -35791,9 +35599,6 @@
                 <a:solidFill>
                   <a:schemeClr val="tx1"/>
                 </a:solidFill>
-                <a:latin typeface="Georgia" pitchFamily="34" charset="0"/>
-                <a:ea typeface="Georgia" pitchFamily="34" charset="-122"/>
-                <a:cs typeface="Georgia" pitchFamily="34" charset="-120"/>
               </a:rPr>
               <a:t>chrF++</a:t>
             </a:r>

</xml_diff>